<commit_message>
Update INARA 2026-09-06 12:33:16
</commit_message>
<xml_diff>
--- a/reports/BRANCH_FLORES_PERFORMANCE_SUMMARY_20260905_INARA.pptx
+++ b/reports/BRANCH_FLORES_PERFORMANCE_SUMMARY_20260905_INARA.pptx
@@ -9761,7 +9761,7 @@
                 <a:gridCol w="958543"/>
                 <a:gridCol w="958543"/>
               </a:tblGrid>
-              <a:tr h="224028">
+              <a:tr h="896112">
                 <a:tc>
                   <a:txBody>
                     <a:bodyPr lIns="27432" rIns="27432" tIns="0" bIns="0" anchor="ctr"/>
@@ -9994,717 +9994,6 @@
                   <a:tcPr marL="27432" marR="27432" marT="0" marB="0">
                     <a:solidFill>
                       <a:srgbClr val="102C50"/>
-                    </a:solidFill>
-                    <a:lnL w="9000" cap="flat" cmpd="sng" algn="ctr">
-                      <a:solidFill>
-                        <a:srgbClr val="D8DEE7"/>
-                      </a:solidFill>
-                      <a:prstDash val="solid"/>
-                    </a:lnL>
-                    <a:lnR w="9000" cap="flat" cmpd="sng" algn="ctr">
-                      <a:solidFill>
-                        <a:srgbClr val="D8DEE7"/>
-                      </a:solidFill>
-                      <a:prstDash val="solid"/>
-                    </a:lnR>
-                    <a:lnT w="9000" cap="flat" cmpd="sng" algn="ctr">
-                      <a:solidFill>
-                        <a:srgbClr val="D8DEE7"/>
-                      </a:solidFill>
-                      <a:prstDash val="solid"/>
-                    </a:lnT>
-                    <a:lnB w="9000" cap="flat" cmpd="sng" algn="ctr">
-                      <a:solidFill>
-                        <a:srgbClr val="D8DEE7"/>
-                      </a:solidFill>
-                      <a:prstDash val="solid"/>
-                    </a:lnB>
-                  </a:tcPr>
-                </a:tc>
-              </a:tr>
-              <a:tr h="224028">
-                <a:tc>
-                  <a:txBody>
-                    <a:bodyPr lIns="27432" rIns="27432" tIns="0" bIns="0" anchor="ctr"/>
-                    <a:lstStyle/>
-                    <a:p>
-                      <a:pPr algn="ctr"/>
-                      <a:r>
-                        <a:rPr sz="1050" b="1">
-                          <a:solidFill>
-                            <a:srgbClr val="20252B"/>
-                          </a:solidFill>
-                          <a:latin typeface="Arial"/>
-                        </a:rPr>
-                        <a:t>Manggarai Barat</a:t>
-                      </a:r>
-                    </a:p>
-                  </a:txBody>
-                  <a:tcPr marL="27432" marR="27432" marT="0" marB="0">
-                    <a:solidFill>
-                      <a:srgbClr val="F4F6F8"/>
-                    </a:solidFill>
-                    <a:lnL w="9000" cap="flat" cmpd="sng" algn="ctr">
-                      <a:solidFill>
-                        <a:srgbClr val="D8DEE7"/>
-                      </a:solidFill>
-                      <a:prstDash val="solid"/>
-                    </a:lnL>
-                    <a:lnR w="9000" cap="flat" cmpd="sng" algn="ctr">
-                      <a:solidFill>
-                        <a:srgbClr val="D8DEE7"/>
-                      </a:solidFill>
-                      <a:prstDash val="solid"/>
-                    </a:lnR>
-                    <a:lnT w="9000" cap="flat" cmpd="sng" algn="ctr">
-                      <a:solidFill>
-                        <a:srgbClr val="D8DEE7"/>
-                      </a:solidFill>
-                      <a:prstDash val="solid"/>
-                    </a:lnT>
-                    <a:lnB w="9000" cap="flat" cmpd="sng" algn="ctr">
-                      <a:solidFill>
-                        <a:srgbClr val="D8DEE7"/>
-                      </a:solidFill>
-                      <a:prstDash val="solid"/>
-                    </a:lnB>
-                  </a:tcPr>
-                </a:tc>
-                <a:tc>
-                  <a:txBody>
-                    <a:bodyPr lIns="27432" rIns="27432" tIns="0" bIns="0" anchor="ctr"/>
-                    <a:lstStyle/>
-                    <a:p>
-                      <a:pPr algn="ctr"/>
-                      <a:r>
-                        <a:rPr sz="1050" b="0">
-                          <a:solidFill>
-                            <a:srgbClr val="20252B"/>
-                          </a:solidFill>
-                          <a:latin typeface="Arial"/>
-                        </a:rPr>
-                        <a:t>11</a:t>
-                      </a:r>
-                    </a:p>
-                  </a:txBody>
-                  <a:tcPr marL="27432" marR="27432" marT="0" marB="0">
-                    <a:solidFill>
-                      <a:srgbClr val="FFFFFF"/>
-                    </a:solidFill>
-                    <a:lnL w="9000" cap="flat" cmpd="sng" algn="ctr">
-                      <a:solidFill>
-                        <a:srgbClr val="D8DEE7"/>
-                      </a:solidFill>
-                      <a:prstDash val="solid"/>
-                    </a:lnL>
-                    <a:lnR w="9000" cap="flat" cmpd="sng" algn="ctr">
-                      <a:solidFill>
-                        <a:srgbClr val="D8DEE7"/>
-                      </a:solidFill>
-                      <a:prstDash val="solid"/>
-                    </a:lnR>
-                    <a:lnT w="9000" cap="flat" cmpd="sng" algn="ctr">
-                      <a:solidFill>
-                        <a:srgbClr val="D8DEE7"/>
-                      </a:solidFill>
-                      <a:prstDash val="solid"/>
-                    </a:lnT>
-                    <a:lnB w="9000" cap="flat" cmpd="sng" algn="ctr">
-                      <a:solidFill>
-                        <a:srgbClr val="D8DEE7"/>
-                      </a:solidFill>
-                      <a:prstDash val="solid"/>
-                    </a:lnB>
-                  </a:tcPr>
-                </a:tc>
-                <a:tc>
-                  <a:txBody>
-                    <a:bodyPr lIns="27432" rIns="27432" tIns="0" bIns="0" anchor="ctr"/>
-                    <a:lstStyle/>
-                    <a:p>
-                      <a:pPr algn="ctr"/>
-                      <a:r>
-                        <a:rPr sz="1050" b="1">
-                          <a:solidFill>
-                            <a:srgbClr val="20252B"/>
-                          </a:solidFill>
-                          <a:latin typeface="Arial"/>
-                        </a:rPr>
-                        <a:t>18</a:t>
-                      </a:r>
-                    </a:p>
-                  </a:txBody>
-                  <a:tcPr marL="27432" marR="27432" marT="0" marB="0">
-                    <a:solidFill>
-                      <a:srgbClr val="FFFFFF"/>
-                    </a:solidFill>
-                    <a:lnL w="9000" cap="flat" cmpd="sng" algn="ctr">
-                      <a:solidFill>
-                        <a:srgbClr val="D8DEE7"/>
-                      </a:solidFill>
-                      <a:prstDash val="solid"/>
-                    </a:lnL>
-                    <a:lnR w="9000" cap="flat" cmpd="sng" algn="ctr">
-                      <a:solidFill>
-                        <a:srgbClr val="D8DEE7"/>
-                      </a:solidFill>
-                      <a:prstDash val="solid"/>
-                    </a:lnR>
-                    <a:lnT w="9000" cap="flat" cmpd="sng" algn="ctr">
-                      <a:solidFill>
-                        <a:srgbClr val="D8DEE7"/>
-                      </a:solidFill>
-                      <a:prstDash val="solid"/>
-                    </a:lnT>
-                    <a:lnB w="9000" cap="flat" cmpd="sng" algn="ctr">
-                      <a:solidFill>
-                        <a:srgbClr val="D8DEE7"/>
-                      </a:solidFill>
-                      <a:prstDash val="solid"/>
-                    </a:lnB>
-                  </a:tcPr>
-                </a:tc>
-                <a:tc>
-                  <a:txBody>
-                    <a:bodyPr lIns="27432" rIns="27432" tIns="0" bIns="0" anchor="ctr"/>
-                    <a:lstStyle/>
-                    <a:p>
-                      <a:pPr algn="ctr"/>
-                      <a:r>
-                        <a:rPr sz="1050" b="0">
-                          <a:solidFill>
-                            <a:srgbClr val="687386"/>
-                          </a:solidFill>
-                          <a:latin typeface="Arial"/>
-                        </a:rPr>
-                        <a:t>7</a:t>
-                      </a:r>
-                    </a:p>
-                  </a:txBody>
-                  <a:tcPr marL="27432" marR="27432" marT="0" marB="0">
-                    <a:solidFill>
-                      <a:srgbClr val="E9EDF2"/>
-                    </a:solidFill>
-                    <a:lnL w="9000" cap="flat" cmpd="sng" algn="ctr">
-                      <a:solidFill>
-                        <a:srgbClr val="D8DEE7"/>
-                      </a:solidFill>
-                      <a:prstDash val="solid"/>
-                    </a:lnL>
-                    <a:lnR w="9000" cap="flat" cmpd="sng" algn="ctr">
-                      <a:solidFill>
-                        <a:srgbClr val="D8DEE7"/>
-                      </a:solidFill>
-                      <a:prstDash val="solid"/>
-                    </a:lnR>
-                    <a:lnT w="9000" cap="flat" cmpd="sng" algn="ctr">
-                      <a:solidFill>
-                        <a:srgbClr val="D8DEE7"/>
-                      </a:solidFill>
-                      <a:prstDash val="solid"/>
-                    </a:lnT>
-                    <a:lnB w="9000" cap="flat" cmpd="sng" algn="ctr">
-                      <a:solidFill>
-                        <a:srgbClr val="D8DEE7"/>
-                      </a:solidFill>
-                      <a:prstDash val="solid"/>
-                    </a:lnB>
-                  </a:tcPr>
-                </a:tc>
-                <a:tc>
-                  <a:txBody>
-                    <a:bodyPr lIns="27432" rIns="27432" tIns="0" bIns="0" anchor="ctr"/>
-                    <a:lstStyle/>
-                    <a:p>
-                      <a:pPr algn="ctr"/>
-                      <a:r>
-                        <a:rPr sz="1050" b="0">
-                          <a:solidFill>
-                            <a:srgbClr val="137D3F"/>
-                          </a:solidFill>
-                          <a:latin typeface="Arial"/>
-                        </a:rPr>
-                        <a:t>+63,6%</a:t>
-                      </a:r>
-                    </a:p>
-                  </a:txBody>
-                  <a:tcPr marL="27432" marR="27432" marT="0" marB="0">
-                    <a:solidFill>
-                      <a:srgbClr val="E5F4EA"/>
-                    </a:solidFill>
-                    <a:lnL w="9000" cap="flat" cmpd="sng" algn="ctr">
-                      <a:solidFill>
-                        <a:srgbClr val="D8DEE7"/>
-                      </a:solidFill>
-                      <a:prstDash val="solid"/>
-                    </a:lnL>
-                    <a:lnR w="9000" cap="flat" cmpd="sng" algn="ctr">
-                      <a:solidFill>
-                        <a:srgbClr val="D8DEE7"/>
-                      </a:solidFill>
-                      <a:prstDash val="solid"/>
-                    </a:lnR>
-                    <a:lnT w="9000" cap="flat" cmpd="sng" algn="ctr">
-                      <a:solidFill>
-                        <a:srgbClr val="D8DEE7"/>
-                      </a:solidFill>
-                      <a:prstDash val="solid"/>
-                    </a:lnT>
-                    <a:lnB w="9000" cap="flat" cmpd="sng" algn="ctr">
-                      <a:solidFill>
-                        <a:srgbClr val="D8DEE7"/>
-                      </a:solidFill>
-                      <a:prstDash val="solid"/>
-                    </a:lnB>
-                  </a:tcPr>
-                </a:tc>
-              </a:tr>
-              <a:tr h="224028">
-                <a:tc>
-                  <a:txBody>
-                    <a:bodyPr lIns="27432" rIns="27432" tIns="0" bIns="0" anchor="ctr"/>
-                    <a:lstStyle/>
-                    <a:p>
-                      <a:pPr algn="ctr"/>
-                      <a:r>
-                        <a:rPr sz="1050" b="1">
-                          <a:solidFill>
-                            <a:srgbClr val="20252B"/>
-                          </a:solidFill>
-                          <a:latin typeface="Arial"/>
-                        </a:rPr>
-                        <a:t>Lembata</a:t>
-                      </a:r>
-                    </a:p>
-                  </a:txBody>
-                  <a:tcPr marL="27432" marR="27432" marT="0" marB="0">
-                    <a:solidFill>
-                      <a:srgbClr val="F4F6F8"/>
-                    </a:solidFill>
-                    <a:lnL w="9000" cap="flat" cmpd="sng" algn="ctr">
-                      <a:solidFill>
-                        <a:srgbClr val="D8DEE7"/>
-                      </a:solidFill>
-                      <a:prstDash val="solid"/>
-                    </a:lnL>
-                    <a:lnR w="9000" cap="flat" cmpd="sng" algn="ctr">
-                      <a:solidFill>
-                        <a:srgbClr val="D8DEE7"/>
-                      </a:solidFill>
-                      <a:prstDash val="solid"/>
-                    </a:lnR>
-                    <a:lnT w="9000" cap="flat" cmpd="sng" algn="ctr">
-                      <a:solidFill>
-                        <a:srgbClr val="D8DEE7"/>
-                      </a:solidFill>
-                      <a:prstDash val="solid"/>
-                    </a:lnT>
-                    <a:lnB w="9000" cap="flat" cmpd="sng" algn="ctr">
-                      <a:solidFill>
-                        <a:srgbClr val="D8DEE7"/>
-                      </a:solidFill>
-                      <a:prstDash val="solid"/>
-                    </a:lnB>
-                  </a:tcPr>
-                </a:tc>
-                <a:tc>
-                  <a:txBody>
-                    <a:bodyPr lIns="27432" rIns="27432" tIns="0" bIns="0" anchor="ctr"/>
-                    <a:lstStyle/>
-                    <a:p>
-                      <a:pPr algn="ctr"/>
-                      <a:r>
-                        <a:rPr sz="1050" b="0">
-                          <a:solidFill>
-                            <a:srgbClr val="20252B"/>
-                          </a:solidFill>
-                          <a:latin typeface="Arial"/>
-                        </a:rPr>
-                        <a:t>8</a:t>
-                      </a:r>
-                    </a:p>
-                  </a:txBody>
-                  <a:tcPr marL="27432" marR="27432" marT="0" marB="0">
-                    <a:solidFill>
-                      <a:srgbClr val="FFFFFF"/>
-                    </a:solidFill>
-                    <a:lnL w="9000" cap="flat" cmpd="sng" algn="ctr">
-                      <a:solidFill>
-                        <a:srgbClr val="D8DEE7"/>
-                      </a:solidFill>
-                      <a:prstDash val="solid"/>
-                    </a:lnL>
-                    <a:lnR w="9000" cap="flat" cmpd="sng" algn="ctr">
-                      <a:solidFill>
-                        <a:srgbClr val="D8DEE7"/>
-                      </a:solidFill>
-                      <a:prstDash val="solid"/>
-                    </a:lnR>
-                    <a:lnT w="9000" cap="flat" cmpd="sng" algn="ctr">
-                      <a:solidFill>
-                        <a:srgbClr val="D8DEE7"/>
-                      </a:solidFill>
-                      <a:prstDash val="solid"/>
-                    </a:lnT>
-                    <a:lnB w="9000" cap="flat" cmpd="sng" algn="ctr">
-                      <a:solidFill>
-                        <a:srgbClr val="D8DEE7"/>
-                      </a:solidFill>
-                      <a:prstDash val="solid"/>
-                    </a:lnB>
-                  </a:tcPr>
-                </a:tc>
-                <a:tc>
-                  <a:txBody>
-                    <a:bodyPr lIns="27432" rIns="27432" tIns="0" bIns="0" anchor="ctr"/>
-                    <a:lstStyle/>
-                    <a:p>
-                      <a:pPr algn="ctr"/>
-                      <a:r>
-                        <a:rPr sz="1050" b="1">
-                          <a:solidFill>
-                            <a:srgbClr val="20252B"/>
-                          </a:solidFill>
-                          <a:latin typeface="Arial"/>
-                        </a:rPr>
-                        <a:t>11</a:t>
-                      </a:r>
-                    </a:p>
-                  </a:txBody>
-                  <a:tcPr marL="27432" marR="27432" marT="0" marB="0">
-                    <a:solidFill>
-                      <a:srgbClr val="FFFFFF"/>
-                    </a:solidFill>
-                    <a:lnL w="9000" cap="flat" cmpd="sng" algn="ctr">
-                      <a:solidFill>
-                        <a:srgbClr val="D8DEE7"/>
-                      </a:solidFill>
-                      <a:prstDash val="solid"/>
-                    </a:lnL>
-                    <a:lnR w="9000" cap="flat" cmpd="sng" algn="ctr">
-                      <a:solidFill>
-                        <a:srgbClr val="D8DEE7"/>
-                      </a:solidFill>
-                      <a:prstDash val="solid"/>
-                    </a:lnR>
-                    <a:lnT w="9000" cap="flat" cmpd="sng" algn="ctr">
-                      <a:solidFill>
-                        <a:srgbClr val="D8DEE7"/>
-                      </a:solidFill>
-                      <a:prstDash val="solid"/>
-                    </a:lnT>
-                    <a:lnB w="9000" cap="flat" cmpd="sng" algn="ctr">
-                      <a:solidFill>
-                        <a:srgbClr val="D8DEE7"/>
-                      </a:solidFill>
-                      <a:prstDash val="solid"/>
-                    </a:lnB>
-                  </a:tcPr>
-                </a:tc>
-                <a:tc>
-                  <a:txBody>
-                    <a:bodyPr lIns="27432" rIns="27432" tIns="0" bIns="0" anchor="ctr"/>
-                    <a:lstStyle/>
-                    <a:p>
-                      <a:pPr algn="ctr"/>
-                      <a:r>
-                        <a:rPr sz="1050" b="0">
-                          <a:solidFill>
-                            <a:srgbClr val="687386"/>
-                          </a:solidFill>
-                          <a:latin typeface="Arial"/>
-                        </a:rPr>
-                        <a:t>3</a:t>
-                      </a:r>
-                    </a:p>
-                  </a:txBody>
-                  <a:tcPr marL="27432" marR="27432" marT="0" marB="0">
-                    <a:solidFill>
-                      <a:srgbClr val="E9EDF2"/>
-                    </a:solidFill>
-                    <a:lnL w="9000" cap="flat" cmpd="sng" algn="ctr">
-                      <a:solidFill>
-                        <a:srgbClr val="D8DEE7"/>
-                      </a:solidFill>
-                      <a:prstDash val="solid"/>
-                    </a:lnL>
-                    <a:lnR w="9000" cap="flat" cmpd="sng" algn="ctr">
-                      <a:solidFill>
-                        <a:srgbClr val="D8DEE7"/>
-                      </a:solidFill>
-                      <a:prstDash val="solid"/>
-                    </a:lnR>
-                    <a:lnT w="9000" cap="flat" cmpd="sng" algn="ctr">
-                      <a:solidFill>
-                        <a:srgbClr val="D8DEE7"/>
-                      </a:solidFill>
-                      <a:prstDash val="solid"/>
-                    </a:lnT>
-                    <a:lnB w="9000" cap="flat" cmpd="sng" algn="ctr">
-                      <a:solidFill>
-                        <a:srgbClr val="D8DEE7"/>
-                      </a:solidFill>
-                      <a:prstDash val="solid"/>
-                    </a:lnB>
-                  </a:tcPr>
-                </a:tc>
-                <a:tc>
-                  <a:txBody>
-                    <a:bodyPr lIns="27432" rIns="27432" tIns="0" bIns="0" anchor="ctr"/>
-                    <a:lstStyle/>
-                    <a:p>
-                      <a:pPr algn="ctr"/>
-                      <a:r>
-                        <a:rPr sz="1050" b="0">
-                          <a:solidFill>
-                            <a:srgbClr val="137D3F"/>
-                          </a:solidFill>
-                          <a:latin typeface="Arial"/>
-                        </a:rPr>
-                        <a:t>+37,5%</a:t>
-                      </a:r>
-                    </a:p>
-                  </a:txBody>
-                  <a:tcPr marL="27432" marR="27432" marT="0" marB="0">
-                    <a:solidFill>
-                      <a:srgbClr val="E5F4EA"/>
-                    </a:solidFill>
-                    <a:lnL w="9000" cap="flat" cmpd="sng" algn="ctr">
-                      <a:solidFill>
-                        <a:srgbClr val="D8DEE7"/>
-                      </a:solidFill>
-                      <a:prstDash val="solid"/>
-                    </a:lnL>
-                    <a:lnR w="9000" cap="flat" cmpd="sng" algn="ctr">
-                      <a:solidFill>
-                        <a:srgbClr val="D8DEE7"/>
-                      </a:solidFill>
-                      <a:prstDash val="solid"/>
-                    </a:lnR>
-                    <a:lnT w="9000" cap="flat" cmpd="sng" algn="ctr">
-                      <a:solidFill>
-                        <a:srgbClr val="D8DEE7"/>
-                      </a:solidFill>
-                      <a:prstDash val="solid"/>
-                    </a:lnT>
-                    <a:lnB w="9000" cap="flat" cmpd="sng" algn="ctr">
-                      <a:solidFill>
-                        <a:srgbClr val="D8DEE7"/>
-                      </a:solidFill>
-                      <a:prstDash val="solid"/>
-                    </a:lnB>
-                  </a:tcPr>
-                </a:tc>
-              </a:tr>
-              <a:tr h="224028">
-                <a:tc>
-                  <a:txBody>
-                    <a:bodyPr lIns="27432" rIns="27432" tIns="0" bIns="0" anchor="ctr"/>
-                    <a:lstStyle/>
-                    <a:p>
-                      <a:pPr algn="ctr"/>
-                      <a:r>
-                        <a:rPr sz="1050" b="1">
-                          <a:solidFill>
-                            <a:srgbClr val="20252B"/>
-                          </a:solidFill>
-                          <a:latin typeface="Arial"/>
-                        </a:rPr>
-                        <a:t>Alor</a:t>
-                      </a:r>
-                    </a:p>
-                  </a:txBody>
-                  <a:tcPr marL="27432" marR="27432" marT="0" marB="0">
-                    <a:solidFill>
-                      <a:srgbClr val="F4F6F8"/>
-                    </a:solidFill>
-                    <a:lnL w="9000" cap="flat" cmpd="sng" algn="ctr">
-                      <a:solidFill>
-                        <a:srgbClr val="D8DEE7"/>
-                      </a:solidFill>
-                      <a:prstDash val="solid"/>
-                    </a:lnL>
-                    <a:lnR w="9000" cap="flat" cmpd="sng" algn="ctr">
-                      <a:solidFill>
-                        <a:srgbClr val="D8DEE7"/>
-                      </a:solidFill>
-                      <a:prstDash val="solid"/>
-                    </a:lnR>
-                    <a:lnT w="9000" cap="flat" cmpd="sng" algn="ctr">
-                      <a:solidFill>
-                        <a:srgbClr val="D8DEE7"/>
-                      </a:solidFill>
-                      <a:prstDash val="solid"/>
-                    </a:lnT>
-                    <a:lnB w="9000" cap="flat" cmpd="sng" algn="ctr">
-                      <a:solidFill>
-                        <a:srgbClr val="D8DEE7"/>
-                      </a:solidFill>
-                      <a:prstDash val="solid"/>
-                    </a:lnB>
-                  </a:tcPr>
-                </a:tc>
-                <a:tc>
-                  <a:txBody>
-                    <a:bodyPr lIns="27432" rIns="27432" tIns="0" bIns="0" anchor="ctr"/>
-                    <a:lstStyle/>
-                    <a:p>
-                      <a:pPr algn="ctr"/>
-                      <a:r>
-                        <a:rPr sz="1050" b="0">
-                          <a:solidFill>
-                            <a:srgbClr val="20252B"/>
-                          </a:solidFill>
-                          <a:latin typeface="Arial"/>
-                        </a:rPr>
-                        <a:t>18</a:t>
-                      </a:r>
-                    </a:p>
-                  </a:txBody>
-                  <a:tcPr marL="27432" marR="27432" marT="0" marB="0">
-                    <a:solidFill>
-                      <a:srgbClr val="FFFFFF"/>
-                    </a:solidFill>
-                    <a:lnL w="9000" cap="flat" cmpd="sng" algn="ctr">
-                      <a:solidFill>
-                        <a:srgbClr val="D8DEE7"/>
-                      </a:solidFill>
-                      <a:prstDash val="solid"/>
-                    </a:lnL>
-                    <a:lnR w="9000" cap="flat" cmpd="sng" algn="ctr">
-                      <a:solidFill>
-                        <a:srgbClr val="D8DEE7"/>
-                      </a:solidFill>
-                      <a:prstDash val="solid"/>
-                    </a:lnR>
-                    <a:lnT w="9000" cap="flat" cmpd="sng" algn="ctr">
-                      <a:solidFill>
-                        <a:srgbClr val="D8DEE7"/>
-                      </a:solidFill>
-                      <a:prstDash val="solid"/>
-                    </a:lnT>
-                    <a:lnB w="9000" cap="flat" cmpd="sng" algn="ctr">
-                      <a:solidFill>
-                        <a:srgbClr val="D8DEE7"/>
-                      </a:solidFill>
-                      <a:prstDash val="solid"/>
-                    </a:lnB>
-                  </a:tcPr>
-                </a:tc>
-                <a:tc>
-                  <a:txBody>
-                    <a:bodyPr lIns="27432" rIns="27432" tIns="0" bIns="0" anchor="ctr"/>
-                    <a:lstStyle/>
-                    <a:p>
-                      <a:pPr algn="ctr"/>
-                      <a:r>
-                        <a:rPr sz="1050" b="1">
-                          <a:solidFill>
-                            <a:srgbClr val="20252B"/>
-                          </a:solidFill>
-                          <a:latin typeface="Arial"/>
-                        </a:rPr>
-                        <a:t>22</a:t>
-                      </a:r>
-                    </a:p>
-                  </a:txBody>
-                  <a:tcPr marL="27432" marR="27432" marT="0" marB="0">
-                    <a:solidFill>
-                      <a:srgbClr val="FFFFFF"/>
-                    </a:solidFill>
-                    <a:lnL w="9000" cap="flat" cmpd="sng" algn="ctr">
-                      <a:solidFill>
-                        <a:srgbClr val="D8DEE7"/>
-                      </a:solidFill>
-                      <a:prstDash val="solid"/>
-                    </a:lnL>
-                    <a:lnR w="9000" cap="flat" cmpd="sng" algn="ctr">
-                      <a:solidFill>
-                        <a:srgbClr val="D8DEE7"/>
-                      </a:solidFill>
-                      <a:prstDash val="solid"/>
-                    </a:lnR>
-                    <a:lnT w="9000" cap="flat" cmpd="sng" algn="ctr">
-                      <a:solidFill>
-                        <a:srgbClr val="D8DEE7"/>
-                      </a:solidFill>
-                      <a:prstDash val="solid"/>
-                    </a:lnT>
-                    <a:lnB w="9000" cap="flat" cmpd="sng" algn="ctr">
-                      <a:solidFill>
-                        <a:srgbClr val="D8DEE7"/>
-                      </a:solidFill>
-                      <a:prstDash val="solid"/>
-                    </a:lnB>
-                  </a:tcPr>
-                </a:tc>
-                <a:tc>
-                  <a:txBody>
-                    <a:bodyPr lIns="27432" rIns="27432" tIns="0" bIns="0" anchor="ctr"/>
-                    <a:lstStyle/>
-                    <a:p>
-                      <a:pPr algn="ctr"/>
-                      <a:r>
-                        <a:rPr sz="1050" b="0">
-                          <a:solidFill>
-                            <a:srgbClr val="687386"/>
-                          </a:solidFill>
-                          <a:latin typeface="Arial"/>
-                        </a:rPr>
-                        <a:t>4</a:t>
-                      </a:r>
-                    </a:p>
-                  </a:txBody>
-                  <a:tcPr marL="27432" marR="27432" marT="0" marB="0">
-                    <a:solidFill>
-                      <a:srgbClr val="E9EDF2"/>
-                    </a:solidFill>
-                    <a:lnL w="9000" cap="flat" cmpd="sng" algn="ctr">
-                      <a:solidFill>
-                        <a:srgbClr val="D8DEE7"/>
-                      </a:solidFill>
-                      <a:prstDash val="solid"/>
-                    </a:lnL>
-                    <a:lnR w="9000" cap="flat" cmpd="sng" algn="ctr">
-                      <a:solidFill>
-                        <a:srgbClr val="D8DEE7"/>
-                      </a:solidFill>
-                      <a:prstDash val="solid"/>
-                    </a:lnR>
-                    <a:lnT w="9000" cap="flat" cmpd="sng" algn="ctr">
-                      <a:solidFill>
-                        <a:srgbClr val="D8DEE7"/>
-                      </a:solidFill>
-                      <a:prstDash val="solid"/>
-                    </a:lnT>
-                    <a:lnB w="9000" cap="flat" cmpd="sng" algn="ctr">
-                      <a:solidFill>
-                        <a:srgbClr val="D8DEE7"/>
-                      </a:solidFill>
-                      <a:prstDash val="solid"/>
-                    </a:lnB>
-                  </a:tcPr>
-                </a:tc>
-                <a:tc>
-                  <a:txBody>
-                    <a:bodyPr lIns="27432" rIns="27432" tIns="0" bIns="0" anchor="ctr"/>
-                    <a:lstStyle/>
-                    <a:p>
-                      <a:pPr algn="ctr"/>
-                      <a:r>
-                        <a:rPr sz="1050" b="0">
-                          <a:solidFill>
-                            <a:srgbClr val="137D3F"/>
-                          </a:solidFill>
-                          <a:latin typeface="Arial"/>
-                        </a:rPr>
-                        <a:t>+22,2%</a:t>
-                      </a:r>
-                    </a:p>
-                  </a:txBody>
-                  <a:tcPr marL="27432" marR="27432" marT="0" marB="0">
-                    <a:solidFill>
-                      <a:srgbClr val="E5F4EA"/>
                     </a:solidFill>
                     <a:lnL w="9000" cap="flat" cmpd="sng" algn="ctr">
                       <a:solidFill>
@@ -10762,7 +10051,7 @@
                 <a:gridCol w="955390"/>
                 <a:gridCol w="955390"/>
               </a:tblGrid>
-              <a:tr h="224028">
+              <a:tr h="896112">
                 <a:tc>
                   <a:txBody>
                     <a:bodyPr lIns="27432" rIns="27432" tIns="0" bIns="0" anchor="ctr"/>
@@ -10995,717 +10284,6 @@
                   <a:tcPr marL="27432" marR="27432" marT="0" marB="0">
                     <a:solidFill>
                       <a:srgbClr val="102C50"/>
-                    </a:solidFill>
-                    <a:lnL w="9000" cap="flat" cmpd="sng" algn="ctr">
-                      <a:solidFill>
-                        <a:srgbClr val="D8DEE7"/>
-                      </a:solidFill>
-                      <a:prstDash val="solid"/>
-                    </a:lnL>
-                    <a:lnR w="9000" cap="flat" cmpd="sng" algn="ctr">
-                      <a:solidFill>
-                        <a:srgbClr val="D8DEE7"/>
-                      </a:solidFill>
-                      <a:prstDash val="solid"/>
-                    </a:lnR>
-                    <a:lnT w="9000" cap="flat" cmpd="sng" algn="ctr">
-                      <a:solidFill>
-                        <a:srgbClr val="D8DEE7"/>
-                      </a:solidFill>
-                      <a:prstDash val="solid"/>
-                    </a:lnT>
-                    <a:lnB w="9000" cap="flat" cmpd="sng" algn="ctr">
-                      <a:solidFill>
-                        <a:srgbClr val="D8DEE7"/>
-                      </a:solidFill>
-                      <a:prstDash val="solid"/>
-                    </a:lnB>
-                  </a:tcPr>
-                </a:tc>
-              </a:tr>
-              <a:tr h="224028">
-                <a:tc>
-                  <a:txBody>
-                    <a:bodyPr lIns="27432" rIns="27432" tIns="0" bIns="0" anchor="ctr"/>
-                    <a:lstStyle/>
-                    <a:p>
-                      <a:pPr algn="ctr"/>
-                      <a:r>
-                        <a:rPr sz="1050" b="1">
-                          <a:solidFill>
-                            <a:srgbClr val="20252B"/>
-                          </a:solidFill>
-                          <a:latin typeface="Arial"/>
-                        </a:rPr>
-                        <a:t>Manggarai</a:t>
-                      </a:r>
-                    </a:p>
-                  </a:txBody>
-                  <a:tcPr marL="27432" marR="27432" marT="0" marB="0">
-                    <a:solidFill>
-                      <a:srgbClr val="F4F6F8"/>
-                    </a:solidFill>
-                    <a:lnL w="9000" cap="flat" cmpd="sng" algn="ctr">
-                      <a:solidFill>
-                        <a:srgbClr val="D8DEE7"/>
-                      </a:solidFill>
-                      <a:prstDash val="solid"/>
-                    </a:lnL>
-                    <a:lnR w="9000" cap="flat" cmpd="sng" algn="ctr">
-                      <a:solidFill>
-                        <a:srgbClr val="D8DEE7"/>
-                      </a:solidFill>
-                      <a:prstDash val="solid"/>
-                    </a:lnR>
-                    <a:lnT w="9000" cap="flat" cmpd="sng" algn="ctr">
-                      <a:solidFill>
-                        <a:srgbClr val="D8DEE7"/>
-                      </a:solidFill>
-                      <a:prstDash val="solid"/>
-                    </a:lnT>
-                    <a:lnB w="9000" cap="flat" cmpd="sng" algn="ctr">
-                      <a:solidFill>
-                        <a:srgbClr val="D8DEE7"/>
-                      </a:solidFill>
-                      <a:prstDash val="solid"/>
-                    </a:lnB>
-                  </a:tcPr>
-                </a:tc>
-                <a:tc>
-                  <a:txBody>
-                    <a:bodyPr lIns="27432" rIns="27432" tIns="0" bIns="0" anchor="ctr"/>
-                    <a:lstStyle/>
-                    <a:p>
-                      <a:pPr algn="ctr"/>
-                      <a:r>
-                        <a:rPr sz="1050" b="0">
-                          <a:solidFill>
-                            <a:srgbClr val="20252B"/>
-                          </a:solidFill>
-                          <a:latin typeface="Arial"/>
-                        </a:rPr>
-                        <a:t>2</a:t>
-                      </a:r>
-                    </a:p>
-                  </a:txBody>
-                  <a:tcPr marL="27432" marR="27432" marT="0" marB="0">
-                    <a:solidFill>
-                      <a:srgbClr val="FFFFFF"/>
-                    </a:solidFill>
-                    <a:lnL w="9000" cap="flat" cmpd="sng" algn="ctr">
-                      <a:solidFill>
-                        <a:srgbClr val="D8DEE7"/>
-                      </a:solidFill>
-                      <a:prstDash val="solid"/>
-                    </a:lnL>
-                    <a:lnR w="9000" cap="flat" cmpd="sng" algn="ctr">
-                      <a:solidFill>
-                        <a:srgbClr val="D8DEE7"/>
-                      </a:solidFill>
-                      <a:prstDash val="solid"/>
-                    </a:lnR>
-                    <a:lnT w="9000" cap="flat" cmpd="sng" algn="ctr">
-                      <a:solidFill>
-                        <a:srgbClr val="D8DEE7"/>
-                      </a:solidFill>
-                      <a:prstDash val="solid"/>
-                    </a:lnT>
-                    <a:lnB w="9000" cap="flat" cmpd="sng" algn="ctr">
-                      <a:solidFill>
-                        <a:srgbClr val="D8DEE7"/>
-                      </a:solidFill>
-                      <a:prstDash val="solid"/>
-                    </a:lnB>
-                  </a:tcPr>
-                </a:tc>
-                <a:tc>
-                  <a:txBody>
-                    <a:bodyPr lIns="27432" rIns="27432" tIns="0" bIns="0" anchor="ctr"/>
-                    <a:lstStyle/>
-                    <a:p>
-                      <a:pPr algn="ctr"/>
-                      <a:r>
-                        <a:rPr sz="1050" b="1">
-                          <a:solidFill>
-                            <a:srgbClr val="20252B"/>
-                          </a:solidFill>
-                          <a:latin typeface="Arial"/>
-                        </a:rPr>
-                        <a:t>0</a:t>
-                      </a:r>
-                    </a:p>
-                  </a:txBody>
-                  <a:tcPr marL="27432" marR="27432" marT="0" marB="0">
-                    <a:solidFill>
-                      <a:srgbClr val="FFFFFF"/>
-                    </a:solidFill>
-                    <a:lnL w="9000" cap="flat" cmpd="sng" algn="ctr">
-                      <a:solidFill>
-                        <a:srgbClr val="D8DEE7"/>
-                      </a:solidFill>
-                      <a:prstDash val="solid"/>
-                    </a:lnL>
-                    <a:lnR w="9000" cap="flat" cmpd="sng" algn="ctr">
-                      <a:solidFill>
-                        <a:srgbClr val="D8DEE7"/>
-                      </a:solidFill>
-                      <a:prstDash val="solid"/>
-                    </a:lnR>
-                    <a:lnT w="9000" cap="flat" cmpd="sng" algn="ctr">
-                      <a:solidFill>
-                        <a:srgbClr val="D8DEE7"/>
-                      </a:solidFill>
-                      <a:prstDash val="solid"/>
-                    </a:lnT>
-                    <a:lnB w="9000" cap="flat" cmpd="sng" algn="ctr">
-                      <a:solidFill>
-                        <a:srgbClr val="D8DEE7"/>
-                      </a:solidFill>
-                      <a:prstDash val="solid"/>
-                    </a:lnB>
-                  </a:tcPr>
-                </a:tc>
-                <a:tc>
-                  <a:txBody>
-                    <a:bodyPr lIns="27432" rIns="27432" tIns="0" bIns="0" anchor="ctr"/>
-                    <a:lstStyle/>
-                    <a:p>
-                      <a:pPr algn="ctr"/>
-                      <a:r>
-                        <a:rPr sz="1050" b="0">
-                          <a:solidFill>
-                            <a:srgbClr val="D73527"/>
-                          </a:solidFill>
-                          <a:latin typeface="Arial"/>
-                        </a:rPr>
-                        <a:t>-2</a:t>
-                      </a:r>
-                    </a:p>
-                  </a:txBody>
-                  <a:tcPr marL="27432" marR="27432" marT="0" marB="0">
-                    <a:solidFill>
-                      <a:srgbClr val="FBE9E7"/>
-                    </a:solidFill>
-                    <a:lnL w="9000" cap="flat" cmpd="sng" algn="ctr">
-                      <a:solidFill>
-                        <a:srgbClr val="D8DEE7"/>
-                      </a:solidFill>
-                      <a:prstDash val="solid"/>
-                    </a:lnL>
-                    <a:lnR w="9000" cap="flat" cmpd="sng" algn="ctr">
-                      <a:solidFill>
-                        <a:srgbClr val="D8DEE7"/>
-                      </a:solidFill>
-                      <a:prstDash val="solid"/>
-                    </a:lnR>
-                    <a:lnT w="9000" cap="flat" cmpd="sng" algn="ctr">
-                      <a:solidFill>
-                        <a:srgbClr val="D8DEE7"/>
-                      </a:solidFill>
-                      <a:prstDash val="solid"/>
-                    </a:lnT>
-                    <a:lnB w="9000" cap="flat" cmpd="sng" algn="ctr">
-                      <a:solidFill>
-                        <a:srgbClr val="D8DEE7"/>
-                      </a:solidFill>
-                      <a:prstDash val="solid"/>
-                    </a:lnB>
-                  </a:tcPr>
-                </a:tc>
-                <a:tc>
-                  <a:txBody>
-                    <a:bodyPr lIns="27432" rIns="27432" tIns="0" bIns="0" anchor="ctr"/>
-                    <a:lstStyle/>
-                    <a:p>
-                      <a:pPr algn="ctr"/>
-                      <a:r>
-                        <a:rPr sz="1050" b="0">
-                          <a:solidFill>
-                            <a:srgbClr val="D73527"/>
-                          </a:solidFill>
-                          <a:latin typeface="Arial"/>
-                        </a:rPr>
-                        <a:t>-100,0%</a:t>
-                      </a:r>
-                    </a:p>
-                  </a:txBody>
-                  <a:tcPr marL="27432" marR="27432" marT="0" marB="0">
-                    <a:solidFill>
-                      <a:srgbClr val="FBE9E7"/>
-                    </a:solidFill>
-                    <a:lnL w="9000" cap="flat" cmpd="sng" algn="ctr">
-                      <a:solidFill>
-                        <a:srgbClr val="D8DEE7"/>
-                      </a:solidFill>
-                      <a:prstDash val="solid"/>
-                    </a:lnL>
-                    <a:lnR w="9000" cap="flat" cmpd="sng" algn="ctr">
-                      <a:solidFill>
-                        <a:srgbClr val="D8DEE7"/>
-                      </a:solidFill>
-                      <a:prstDash val="solid"/>
-                    </a:lnR>
-                    <a:lnT w="9000" cap="flat" cmpd="sng" algn="ctr">
-                      <a:solidFill>
-                        <a:srgbClr val="D8DEE7"/>
-                      </a:solidFill>
-                      <a:prstDash val="solid"/>
-                    </a:lnT>
-                    <a:lnB w="9000" cap="flat" cmpd="sng" algn="ctr">
-                      <a:solidFill>
-                        <a:srgbClr val="D8DEE7"/>
-                      </a:solidFill>
-                      <a:prstDash val="solid"/>
-                    </a:lnB>
-                  </a:tcPr>
-                </a:tc>
-              </a:tr>
-              <a:tr h="224028">
-                <a:tc>
-                  <a:txBody>
-                    <a:bodyPr lIns="27432" rIns="27432" tIns="0" bIns="0" anchor="ctr"/>
-                    <a:lstStyle/>
-                    <a:p>
-                      <a:pPr algn="ctr"/>
-                      <a:r>
-                        <a:rPr sz="1050" b="1">
-                          <a:solidFill>
-                            <a:srgbClr val="20252B"/>
-                          </a:solidFill>
-                          <a:latin typeface="Arial"/>
-                        </a:rPr>
-                        <a:t>Flores Timur</a:t>
-                      </a:r>
-                    </a:p>
-                  </a:txBody>
-                  <a:tcPr marL="27432" marR="27432" marT="0" marB="0">
-                    <a:solidFill>
-                      <a:srgbClr val="F4F6F8"/>
-                    </a:solidFill>
-                    <a:lnL w="9000" cap="flat" cmpd="sng" algn="ctr">
-                      <a:solidFill>
-                        <a:srgbClr val="D8DEE7"/>
-                      </a:solidFill>
-                      <a:prstDash val="solid"/>
-                    </a:lnL>
-                    <a:lnR w="9000" cap="flat" cmpd="sng" algn="ctr">
-                      <a:solidFill>
-                        <a:srgbClr val="D8DEE7"/>
-                      </a:solidFill>
-                      <a:prstDash val="solid"/>
-                    </a:lnR>
-                    <a:lnT w="9000" cap="flat" cmpd="sng" algn="ctr">
-                      <a:solidFill>
-                        <a:srgbClr val="D8DEE7"/>
-                      </a:solidFill>
-                      <a:prstDash val="solid"/>
-                    </a:lnT>
-                    <a:lnB w="9000" cap="flat" cmpd="sng" algn="ctr">
-                      <a:solidFill>
-                        <a:srgbClr val="D8DEE7"/>
-                      </a:solidFill>
-                      <a:prstDash val="solid"/>
-                    </a:lnB>
-                  </a:tcPr>
-                </a:tc>
-                <a:tc>
-                  <a:txBody>
-                    <a:bodyPr lIns="27432" rIns="27432" tIns="0" bIns="0" anchor="ctr"/>
-                    <a:lstStyle/>
-                    <a:p>
-                      <a:pPr algn="ctr"/>
-                      <a:r>
-                        <a:rPr sz="1050" b="0">
-                          <a:solidFill>
-                            <a:srgbClr val="20252B"/>
-                          </a:solidFill>
-                          <a:latin typeface="Arial"/>
-                        </a:rPr>
-                        <a:t>14</a:t>
-                      </a:r>
-                    </a:p>
-                  </a:txBody>
-                  <a:tcPr marL="27432" marR="27432" marT="0" marB="0">
-                    <a:solidFill>
-                      <a:srgbClr val="FFFFFF"/>
-                    </a:solidFill>
-                    <a:lnL w="9000" cap="flat" cmpd="sng" algn="ctr">
-                      <a:solidFill>
-                        <a:srgbClr val="D8DEE7"/>
-                      </a:solidFill>
-                      <a:prstDash val="solid"/>
-                    </a:lnL>
-                    <a:lnR w="9000" cap="flat" cmpd="sng" algn="ctr">
-                      <a:solidFill>
-                        <a:srgbClr val="D8DEE7"/>
-                      </a:solidFill>
-                      <a:prstDash val="solid"/>
-                    </a:lnR>
-                    <a:lnT w="9000" cap="flat" cmpd="sng" algn="ctr">
-                      <a:solidFill>
-                        <a:srgbClr val="D8DEE7"/>
-                      </a:solidFill>
-                      <a:prstDash val="solid"/>
-                    </a:lnT>
-                    <a:lnB w="9000" cap="flat" cmpd="sng" algn="ctr">
-                      <a:solidFill>
-                        <a:srgbClr val="D8DEE7"/>
-                      </a:solidFill>
-                      <a:prstDash val="solid"/>
-                    </a:lnB>
-                  </a:tcPr>
-                </a:tc>
-                <a:tc>
-                  <a:txBody>
-                    <a:bodyPr lIns="27432" rIns="27432" tIns="0" bIns="0" anchor="ctr"/>
-                    <a:lstStyle/>
-                    <a:p>
-                      <a:pPr algn="ctr"/>
-                      <a:r>
-                        <a:rPr sz="1050" b="1">
-                          <a:solidFill>
-                            <a:srgbClr val="20252B"/>
-                          </a:solidFill>
-                          <a:latin typeface="Arial"/>
-                        </a:rPr>
-                        <a:t>11</a:t>
-                      </a:r>
-                    </a:p>
-                  </a:txBody>
-                  <a:tcPr marL="27432" marR="27432" marT="0" marB="0">
-                    <a:solidFill>
-                      <a:srgbClr val="FFFFFF"/>
-                    </a:solidFill>
-                    <a:lnL w="9000" cap="flat" cmpd="sng" algn="ctr">
-                      <a:solidFill>
-                        <a:srgbClr val="D8DEE7"/>
-                      </a:solidFill>
-                      <a:prstDash val="solid"/>
-                    </a:lnL>
-                    <a:lnR w="9000" cap="flat" cmpd="sng" algn="ctr">
-                      <a:solidFill>
-                        <a:srgbClr val="D8DEE7"/>
-                      </a:solidFill>
-                      <a:prstDash val="solid"/>
-                    </a:lnR>
-                    <a:lnT w="9000" cap="flat" cmpd="sng" algn="ctr">
-                      <a:solidFill>
-                        <a:srgbClr val="D8DEE7"/>
-                      </a:solidFill>
-                      <a:prstDash val="solid"/>
-                    </a:lnT>
-                    <a:lnB w="9000" cap="flat" cmpd="sng" algn="ctr">
-                      <a:solidFill>
-                        <a:srgbClr val="D8DEE7"/>
-                      </a:solidFill>
-                      <a:prstDash val="solid"/>
-                    </a:lnB>
-                  </a:tcPr>
-                </a:tc>
-                <a:tc>
-                  <a:txBody>
-                    <a:bodyPr lIns="27432" rIns="27432" tIns="0" bIns="0" anchor="ctr"/>
-                    <a:lstStyle/>
-                    <a:p>
-                      <a:pPr algn="ctr"/>
-                      <a:r>
-                        <a:rPr sz="1050" b="0">
-                          <a:solidFill>
-                            <a:srgbClr val="D73527"/>
-                          </a:solidFill>
-                          <a:latin typeface="Arial"/>
-                        </a:rPr>
-                        <a:t>-3</a:t>
-                      </a:r>
-                    </a:p>
-                  </a:txBody>
-                  <a:tcPr marL="27432" marR="27432" marT="0" marB="0">
-                    <a:solidFill>
-                      <a:srgbClr val="FBE9E7"/>
-                    </a:solidFill>
-                    <a:lnL w="9000" cap="flat" cmpd="sng" algn="ctr">
-                      <a:solidFill>
-                        <a:srgbClr val="D8DEE7"/>
-                      </a:solidFill>
-                      <a:prstDash val="solid"/>
-                    </a:lnL>
-                    <a:lnR w="9000" cap="flat" cmpd="sng" algn="ctr">
-                      <a:solidFill>
-                        <a:srgbClr val="D8DEE7"/>
-                      </a:solidFill>
-                      <a:prstDash val="solid"/>
-                    </a:lnR>
-                    <a:lnT w="9000" cap="flat" cmpd="sng" algn="ctr">
-                      <a:solidFill>
-                        <a:srgbClr val="D8DEE7"/>
-                      </a:solidFill>
-                      <a:prstDash val="solid"/>
-                    </a:lnT>
-                    <a:lnB w="9000" cap="flat" cmpd="sng" algn="ctr">
-                      <a:solidFill>
-                        <a:srgbClr val="D8DEE7"/>
-                      </a:solidFill>
-                      <a:prstDash val="solid"/>
-                    </a:lnB>
-                  </a:tcPr>
-                </a:tc>
-                <a:tc>
-                  <a:txBody>
-                    <a:bodyPr lIns="27432" rIns="27432" tIns="0" bIns="0" anchor="ctr"/>
-                    <a:lstStyle/>
-                    <a:p>
-                      <a:pPr algn="ctr"/>
-                      <a:r>
-                        <a:rPr sz="1050" b="0">
-                          <a:solidFill>
-                            <a:srgbClr val="D73527"/>
-                          </a:solidFill>
-                          <a:latin typeface="Arial"/>
-                        </a:rPr>
-                        <a:t>-21,4%</a:t>
-                      </a:r>
-                    </a:p>
-                  </a:txBody>
-                  <a:tcPr marL="27432" marR="27432" marT="0" marB="0">
-                    <a:solidFill>
-                      <a:srgbClr val="FBE9E7"/>
-                    </a:solidFill>
-                    <a:lnL w="9000" cap="flat" cmpd="sng" algn="ctr">
-                      <a:solidFill>
-                        <a:srgbClr val="D8DEE7"/>
-                      </a:solidFill>
-                      <a:prstDash val="solid"/>
-                    </a:lnL>
-                    <a:lnR w="9000" cap="flat" cmpd="sng" algn="ctr">
-                      <a:solidFill>
-                        <a:srgbClr val="D8DEE7"/>
-                      </a:solidFill>
-                      <a:prstDash val="solid"/>
-                    </a:lnR>
-                    <a:lnT w="9000" cap="flat" cmpd="sng" algn="ctr">
-                      <a:solidFill>
-                        <a:srgbClr val="D8DEE7"/>
-                      </a:solidFill>
-                      <a:prstDash val="solid"/>
-                    </a:lnT>
-                    <a:lnB w="9000" cap="flat" cmpd="sng" algn="ctr">
-                      <a:solidFill>
-                        <a:srgbClr val="D8DEE7"/>
-                      </a:solidFill>
-                      <a:prstDash val="solid"/>
-                    </a:lnB>
-                  </a:tcPr>
-                </a:tc>
-              </a:tr>
-              <a:tr h="224028">
-                <a:tc>
-                  <a:txBody>
-                    <a:bodyPr lIns="27432" rIns="27432" tIns="0" bIns="0" anchor="ctr"/>
-                    <a:lstStyle/>
-                    <a:p>
-                      <a:pPr algn="ctr"/>
-                      <a:r>
-                        <a:rPr sz="1050" b="1">
-                          <a:solidFill>
-                            <a:srgbClr val="20252B"/>
-                          </a:solidFill>
-                          <a:latin typeface="Arial"/>
-                        </a:rPr>
-                        <a:t>Sikka</a:t>
-                      </a:r>
-                    </a:p>
-                  </a:txBody>
-                  <a:tcPr marL="27432" marR="27432" marT="0" marB="0">
-                    <a:solidFill>
-                      <a:srgbClr val="F4F6F8"/>
-                    </a:solidFill>
-                    <a:lnL w="9000" cap="flat" cmpd="sng" algn="ctr">
-                      <a:solidFill>
-                        <a:srgbClr val="D8DEE7"/>
-                      </a:solidFill>
-                      <a:prstDash val="solid"/>
-                    </a:lnL>
-                    <a:lnR w="9000" cap="flat" cmpd="sng" algn="ctr">
-                      <a:solidFill>
-                        <a:srgbClr val="D8DEE7"/>
-                      </a:solidFill>
-                      <a:prstDash val="solid"/>
-                    </a:lnR>
-                    <a:lnT w="9000" cap="flat" cmpd="sng" algn="ctr">
-                      <a:solidFill>
-                        <a:srgbClr val="D8DEE7"/>
-                      </a:solidFill>
-                      <a:prstDash val="solid"/>
-                    </a:lnT>
-                    <a:lnB w="9000" cap="flat" cmpd="sng" algn="ctr">
-                      <a:solidFill>
-                        <a:srgbClr val="D8DEE7"/>
-                      </a:solidFill>
-                      <a:prstDash val="solid"/>
-                    </a:lnB>
-                  </a:tcPr>
-                </a:tc>
-                <a:tc>
-                  <a:txBody>
-                    <a:bodyPr lIns="27432" rIns="27432" tIns="0" bIns="0" anchor="ctr"/>
-                    <a:lstStyle/>
-                    <a:p>
-                      <a:pPr algn="ctr"/>
-                      <a:r>
-                        <a:rPr sz="1050" b="0">
-                          <a:solidFill>
-                            <a:srgbClr val="20252B"/>
-                          </a:solidFill>
-                          <a:latin typeface="Arial"/>
-                        </a:rPr>
-                        <a:t>39</a:t>
-                      </a:r>
-                    </a:p>
-                  </a:txBody>
-                  <a:tcPr marL="27432" marR="27432" marT="0" marB="0">
-                    <a:solidFill>
-                      <a:srgbClr val="FFFFFF"/>
-                    </a:solidFill>
-                    <a:lnL w="9000" cap="flat" cmpd="sng" algn="ctr">
-                      <a:solidFill>
-                        <a:srgbClr val="D8DEE7"/>
-                      </a:solidFill>
-                      <a:prstDash val="solid"/>
-                    </a:lnL>
-                    <a:lnR w="9000" cap="flat" cmpd="sng" algn="ctr">
-                      <a:solidFill>
-                        <a:srgbClr val="D8DEE7"/>
-                      </a:solidFill>
-                      <a:prstDash val="solid"/>
-                    </a:lnR>
-                    <a:lnT w="9000" cap="flat" cmpd="sng" algn="ctr">
-                      <a:solidFill>
-                        <a:srgbClr val="D8DEE7"/>
-                      </a:solidFill>
-                      <a:prstDash val="solid"/>
-                    </a:lnT>
-                    <a:lnB w="9000" cap="flat" cmpd="sng" algn="ctr">
-                      <a:solidFill>
-                        <a:srgbClr val="D8DEE7"/>
-                      </a:solidFill>
-                      <a:prstDash val="solid"/>
-                    </a:lnB>
-                  </a:tcPr>
-                </a:tc>
-                <a:tc>
-                  <a:txBody>
-                    <a:bodyPr lIns="27432" rIns="27432" tIns="0" bIns="0" anchor="ctr"/>
-                    <a:lstStyle/>
-                    <a:p>
-                      <a:pPr algn="ctr"/>
-                      <a:r>
-                        <a:rPr sz="1050" b="1">
-                          <a:solidFill>
-                            <a:srgbClr val="20252B"/>
-                          </a:solidFill>
-                          <a:latin typeface="Arial"/>
-                        </a:rPr>
-                        <a:t>41</a:t>
-                      </a:r>
-                    </a:p>
-                  </a:txBody>
-                  <a:tcPr marL="27432" marR="27432" marT="0" marB="0">
-                    <a:solidFill>
-                      <a:srgbClr val="FFFFFF"/>
-                    </a:solidFill>
-                    <a:lnL w="9000" cap="flat" cmpd="sng" algn="ctr">
-                      <a:solidFill>
-                        <a:srgbClr val="D8DEE7"/>
-                      </a:solidFill>
-                      <a:prstDash val="solid"/>
-                    </a:lnL>
-                    <a:lnR w="9000" cap="flat" cmpd="sng" algn="ctr">
-                      <a:solidFill>
-                        <a:srgbClr val="D8DEE7"/>
-                      </a:solidFill>
-                      <a:prstDash val="solid"/>
-                    </a:lnR>
-                    <a:lnT w="9000" cap="flat" cmpd="sng" algn="ctr">
-                      <a:solidFill>
-                        <a:srgbClr val="D8DEE7"/>
-                      </a:solidFill>
-                      <a:prstDash val="solid"/>
-                    </a:lnT>
-                    <a:lnB w="9000" cap="flat" cmpd="sng" algn="ctr">
-                      <a:solidFill>
-                        <a:srgbClr val="D8DEE7"/>
-                      </a:solidFill>
-                      <a:prstDash val="solid"/>
-                    </a:lnB>
-                  </a:tcPr>
-                </a:tc>
-                <a:tc>
-                  <a:txBody>
-                    <a:bodyPr lIns="27432" rIns="27432" tIns="0" bIns="0" anchor="ctr"/>
-                    <a:lstStyle/>
-                    <a:p>
-                      <a:pPr algn="ctr"/>
-                      <a:r>
-                        <a:rPr sz="1050" b="0">
-                          <a:solidFill>
-                            <a:srgbClr val="687386"/>
-                          </a:solidFill>
-                          <a:latin typeface="Arial"/>
-                        </a:rPr>
-                        <a:t>2</a:t>
-                      </a:r>
-                    </a:p>
-                  </a:txBody>
-                  <a:tcPr marL="27432" marR="27432" marT="0" marB="0">
-                    <a:solidFill>
-                      <a:srgbClr val="E9EDF2"/>
-                    </a:solidFill>
-                    <a:lnL w="9000" cap="flat" cmpd="sng" algn="ctr">
-                      <a:solidFill>
-                        <a:srgbClr val="D8DEE7"/>
-                      </a:solidFill>
-                      <a:prstDash val="solid"/>
-                    </a:lnL>
-                    <a:lnR w="9000" cap="flat" cmpd="sng" algn="ctr">
-                      <a:solidFill>
-                        <a:srgbClr val="D8DEE7"/>
-                      </a:solidFill>
-                      <a:prstDash val="solid"/>
-                    </a:lnR>
-                    <a:lnT w="9000" cap="flat" cmpd="sng" algn="ctr">
-                      <a:solidFill>
-                        <a:srgbClr val="D8DEE7"/>
-                      </a:solidFill>
-                      <a:prstDash val="solid"/>
-                    </a:lnT>
-                    <a:lnB w="9000" cap="flat" cmpd="sng" algn="ctr">
-                      <a:solidFill>
-                        <a:srgbClr val="D8DEE7"/>
-                      </a:solidFill>
-                      <a:prstDash val="solid"/>
-                    </a:lnB>
-                  </a:tcPr>
-                </a:tc>
-                <a:tc>
-                  <a:txBody>
-                    <a:bodyPr lIns="27432" rIns="27432" tIns="0" bIns="0" anchor="ctr"/>
-                    <a:lstStyle/>
-                    <a:p>
-                      <a:pPr algn="ctr"/>
-                      <a:r>
-                        <a:rPr sz="1050" b="0">
-                          <a:solidFill>
-                            <a:srgbClr val="137D3F"/>
-                          </a:solidFill>
-                          <a:latin typeface="Arial"/>
-                        </a:rPr>
-                        <a:t>+5,1%</a:t>
-                      </a:r>
-                    </a:p>
-                  </a:txBody>
-                  <a:tcPr marL="27432" marR="27432" marT="0" marB="0">
-                    <a:solidFill>
-                      <a:srgbClr val="E5F4EA"/>
                     </a:solidFill>
                     <a:lnL w="9000" cap="flat" cmpd="sng" algn="ctr">
                       <a:solidFill>

</xml_diff>